<commit_message>
Corregir CP-W10 inestable: esperar el alta del contacto
El run #13 marcó CP-W10 como flaky: la prueba abría la pantalla de
solicitudes antes de que terminara de guardarse el contacto, y la lista
cargaba sin él. Registra el caso en el informe y en la presentación.

Co-Authored-By: Claude Opus 5.5 <noreply@anthropic.com>
</commit_message>
<xml_diff>
--- a/docs/Entrega2_G4_E2E_CICD.pptx
+++ b/docs/Entrega2_G4_E2E_CICD.pptx
@@ -125,13 +125,13 @@
   <p:extLst>
     <p:ext uri="{521415D9-36F7-43E2-AB2F-B90AF26B5E84}">
       <p14:sectionLst xmlns:p14="http://schemas.microsoft.com/office/powerpoint/2010/main">
-        <p14:section name="Resumen" id="{60a976ec-5032-733a-43e7-0231ae633453}">
+        <p14:section name="Resumen" id="{7c682012-0f05-dc2f-8412-6fe2f3dd1bc4}">
           <p14:sldIdLst>
             <p14:sldId id="256"/>
             <p14:sldId id="257"/>
           </p14:sldIdLst>
         </p14:section>
-        <p14:section name="Automatización" id="{896d0be0-a1ea-a07f-78f7-bc54690ae1fa}">
+        <p14:section name="Automatización" id="{50fec293-6546-4f79-71de-99d3328d4538}">
           <p14:sldIdLst>
             <p14:sldId id="258"/>
             <p14:sldId id="259"/>
@@ -141,7 +141,7 @@
             <p14:sldId id="263"/>
           </p14:sldIdLst>
         </p14:section>
-        <p14:section name="Pipeline" id="{cc513362-cee4-ac0e-219d-9ea2ef86abdf}">
+        <p14:section name="Pipeline" id="{8444bd69-a065-aabd-15cd-143b8d989d2f}">
           <p14:sldIdLst>
             <p14:sldId id="264"/>
             <p14:sldId id="265"/>
@@ -151,12 +151,12 @@
             <p14:sldId id="269"/>
           </p14:sldIdLst>
         </p14:section>
-        <p14:section name="Trazabilidad" id="{45c68536-737c-c202-b342-99f5f851d902}">
+        <p14:section name="Trazabilidad" id="{f017b571-b543-10af-3221-a37423524f5f}">
           <p14:sldIdLst>
             <p14:sldId id="270"/>
           </p14:sldIdLst>
         </p14:section>
-        <p14:section name="Hallazgos" id="{731a390f-bcf6-7381-59ea-0f9b1764d3b9}">
+        <p14:section name="Hallazgos" id="{527c8c32-8d6d-cd61-ef68-eb3aae5c93d5}">
           <p14:sldIdLst>
             <p14:sldId id="271"/>
             <p14:sldId id="272"/>
@@ -1331,7 +1331,7 @@
           <a:p>
             <a:r>
               <a:rPr lang="en-US" dirty="0"/>
-              <a:t>Este es un run real, disparado solo al entrar el cambio a main. Tres jobs en verde en poco más de 3 minutos. A la derecha está lo que escribe el resumen del job, con conteos que salen del JUnit XML. Abajo está toda la historia: 10 runs. Los rojos también son evidencia: el 1 y el 2 encontraron defectos reales, y el 8 es el PR que rompe una prueba a propósito.</a:t>
+              <a:t>Este es un run real, disparado solo al entrar el cambio a main. Tres jobs en verde en poco más de 3 minutos. A la derecha está lo que escribe el resumen del job, con conteos que salen del JUnit XML. Abajo están los primeros 10 runs. Los rojos también son evidencia: el 1 y el 2 encontraron defectos reales, y el 8 es el PR que rompe una prueba a propósito.</a:t>
             </a:r>
             <a:endParaRPr lang="en-US" dirty="0"/>
           </a:p>
@@ -1683,7 +1683,7 @@
           <a:p>
             <a:r>
               <a:rPr lang="en-US" dirty="0"/>
-              <a:t>Tomé los cuatro casos del ejercicio 2 de la clase y los busqué en mi pipeline. El caso A es mi run 10: los 4 xfail tienen defecto reportado, así que pasa. El caso B me pasó de verdad en el run 1: en mi máquina todo pasaba, pero la referencia es el pipeline. El caso C no ocurrió, pero failOnFlakyTests lo bloquearía. Y el caso D es el PR 3. Verde no significa sin problemas.</a:t>
+              <a:t>Tomé los cuatro casos del ejercicio 2 de la clase y los busqué en mi pipeline. El caso A es mi run 10: los 4 xfail tienen defecto reportado, así que pasa. El caso B me pasó de verdad en el run 1: en mi máquina todo pasaba, pero la referencia es el pipeline. El caso C me pasó en el run 13: CP-W10 falló y pasó en el reintento, y failOnFlakyTests puso el pipeline en rojo. La prueba no esperaba a que se guardara el contacto, y la corregí. Y el caso D es el PR 3. Verde no significa sin problemas.</a:t>
             </a:r>
             <a:endParaRPr lang="en-US" dirty="0"/>
           </a:p>
@@ -5492,7 +5492,7 @@
                   <a:schemeClr val="tx2"/>
                 </a:solidFill>
               </a:rPr>
-              <a:t>Historia real del pipeline: los 10 runs</a:t>
+              <a:t>Historia real del pipeline: los primeros 10 runs</a:t>
             </a:r>
             <a:endParaRPr lang="en-US" sz="1600" dirty="0"/>
           </a:p>
@@ -9083,10 +9083,10 @@
                       <a:r>
                         <a:rPr lang="en-US" sz="1500" b="1" dirty="0">
                           <a:solidFill>
-                            <a:schemeClr val="accent3"/>
+                            <a:srgbClr val="C0392B"/>
                           </a:solidFill>
                         </a:rPr>
-                        <a:t>Run #10: 0 flaky en 57</a:t>
+                        <a:t>Run #13: 1 flaky en CP-W10, rojo y corregido</a:t>
                       </a:r>
                       <a:endParaRPr lang="en-US" sz="1500" dirty="0"/>
                     </a:p>
@@ -10519,7 +10519,7 @@
                             <a:schemeClr val="tx1"/>
                           </a:solidFill>
                         </a:rPr>
-                        <a:t>No ocurrió: 0 flaky en 57. failOnFlakyTests está activo en CI</a:t>
+                        <a:t>Run #13, PR #6. CP-W10 falló y pasó en el reintento: 56 passed, 1 flaky</a:t>
                       </a:r>
                       <a:endParaRPr lang="en-US" sz="1500" dirty="0"/>
                     </a:p>
@@ -10574,10 +10574,10 @@
                       <a:r>
                         <a:rPr lang="en-US" sz="1500" b="1" dirty="0">
                           <a:solidFill>
-                            <a:schemeClr val="tx2"/>
+                            <a:srgbClr val="C0392B"/>
                           </a:solidFill>
                         </a:rPr>
-                        <a:t>Lo bloquea</a:t>
+                        <a:t>No</a:t>
                       </a:r>
                       <a:endParaRPr lang="en-US" sz="1500" dirty="0"/>
                     </a:p>
@@ -10620,7 +10620,7 @@
                       <a:tailEnd type="none" w="med" len="med"/>
                     </a:lnB>
                     <a:solidFill>
-                      <a:srgbClr val="FBF0D1"/>
+                      <a:srgbClr val="F9E1DE"/>
                     </a:solidFill>
                   </a:tcPr>
                 </a:tc>
@@ -10638,7 +10638,7 @@
                             <a:schemeClr val="tx1"/>
                           </a:solidFill>
                         </a:rPr>
-                        <a:t>Un flaky pondría el pipeline en rojo para investigarlo</a:t>
+                        <a:t>failOnFlakyTests lo bloqueó. La prueba no esperaba el alta: corregida</a:t>
                       </a:r>
                       <a:endParaRPr lang="en-US" sz="1500" dirty="0"/>
                     </a:p>
@@ -14696,7 +14696,7 @@
                             <a:schemeClr val="tx1"/>
                           </a:solidFill>
                         </a:rPr>
-                        <a:t>10 runs</a:t>
+                        <a:t>Más de 10 runs</a:t>
                       </a:r>
                       <a:endParaRPr lang="en-US" sz="1500" dirty="0"/>
                     </a:p>

</xml_diff>